<commit_message>
(fix) Removed ScriptTask to capture result
</commit_message>
<xml_diff>
--- a/examples/orchestrator-agent/docs/orchestrator-agent.pptx
+++ b/examples/orchestrator-agent/docs/orchestrator-agent.pptx
@@ -104,6 +104,11 @@
       </a:defRPr>
     </a:lvl9pPr>
   </p:defaultTextStyle>
+  <p:extLst>
+    <p:ext uri="{EFAFB233-063F-42B5-8137-9DF3F51BA10A}">
+      <p15:sldGuideLst xmlns:p15="http://schemas.microsoft.com/office/powerpoint/2012/main"/>
+    </p:ext>
+  </p:extLst>
 </p:presentation>
 </file>
 
@@ -256,7 +261,7 @@
           <a:p>
             <a:fld id="{FDD66248-7FCF-479B-9C79-503AAD01293A}" type="datetimeFigureOut">
               <a:rPr lang="en-DE" smtClean="0"/>
-              <a:t>23/07/2026</a:t>
+              <a:t>29/07/2026</a:t>
             </a:fld>
             <a:endParaRPr lang="en-DE"/>
           </a:p>
@@ -456,7 +461,7 @@
           <a:p>
             <a:fld id="{FDD66248-7FCF-479B-9C79-503AAD01293A}" type="datetimeFigureOut">
               <a:rPr lang="en-DE" smtClean="0"/>
-              <a:t>23/07/2026</a:t>
+              <a:t>29/07/2026</a:t>
             </a:fld>
             <a:endParaRPr lang="en-DE"/>
           </a:p>
@@ -666,7 +671,7 @@
           <a:p>
             <a:fld id="{FDD66248-7FCF-479B-9C79-503AAD01293A}" type="datetimeFigureOut">
               <a:rPr lang="en-DE" smtClean="0"/>
-              <a:t>23/07/2026</a:t>
+              <a:t>29/07/2026</a:t>
             </a:fld>
             <a:endParaRPr lang="en-DE"/>
           </a:p>
@@ -866,7 +871,7 @@
           <a:p>
             <a:fld id="{FDD66248-7FCF-479B-9C79-503AAD01293A}" type="datetimeFigureOut">
               <a:rPr lang="en-DE" smtClean="0"/>
-              <a:t>23/07/2026</a:t>
+              <a:t>29/07/2026</a:t>
             </a:fld>
             <a:endParaRPr lang="en-DE"/>
           </a:p>
@@ -1142,7 +1147,7 @@
           <a:p>
             <a:fld id="{FDD66248-7FCF-479B-9C79-503AAD01293A}" type="datetimeFigureOut">
               <a:rPr lang="en-DE" smtClean="0"/>
-              <a:t>23/07/2026</a:t>
+              <a:t>29/07/2026</a:t>
             </a:fld>
             <a:endParaRPr lang="en-DE"/>
           </a:p>
@@ -1410,7 +1415,7 @@
           <a:p>
             <a:fld id="{FDD66248-7FCF-479B-9C79-503AAD01293A}" type="datetimeFigureOut">
               <a:rPr lang="en-DE" smtClean="0"/>
-              <a:t>23/07/2026</a:t>
+              <a:t>29/07/2026</a:t>
             </a:fld>
             <a:endParaRPr lang="en-DE"/>
           </a:p>
@@ -1825,7 +1830,7 @@
           <a:p>
             <a:fld id="{FDD66248-7FCF-479B-9C79-503AAD01293A}" type="datetimeFigureOut">
               <a:rPr lang="en-DE" smtClean="0"/>
-              <a:t>23/07/2026</a:t>
+              <a:t>29/07/2026</a:t>
             </a:fld>
             <a:endParaRPr lang="en-DE"/>
           </a:p>
@@ -1967,7 +1972,7 @@
           <a:p>
             <a:fld id="{FDD66248-7FCF-479B-9C79-503AAD01293A}" type="datetimeFigureOut">
               <a:rPr lang="en-DE" smtClean="0"/>
-              <a:t>23/07/2026</a:t>
+              <a:t>29/07/2026</a:t>
             </a:fld>
             <a:endParaRPr lang="en-DE"/>
           </a:p>
@@ -2080,7 +2085,7 @@
           <a:p>
             <a:fld id="{FDD66248-7FCF-479B-9C79-503AAD01293A}" type="datetimeFigureOut">
               <a:rPr lang="en-DE" smtClean="0"/>
-              <a:t>23/07/2026</a:t>
+              <a:t>29/07/2026</a:t>
             </a:fld>
             <a:endParaRPr lang="en-DE"/>
           </a:p>
@@ -2393,7 +2398,7 @@
           <a:p>
             <a:fld id="{FDD66248-7FCF-479B-9C79-503AAD01293A}" type="datetimeFigureOut">
               <a:rPr lang="en-DE" smtClean="0"/>
-              <a:t>23/07/2026</a:t>
+              <a:t>29/07/2026</a:t>
             </a:fld>
             <a:endParaRPr lang="en-DE"/>
           </a:p>
@@ -2682,7 +2687,7 @@
           <a:p>
             <a:fld id="{FDD66248-7FCF-479B-9C79-503AAD01293A}" type="datetimeFigureOut">
               <a:rPr lang="en-DE" smtClean="0"/>
-              <a:t>23/07/2026</a:t>
+              <a:t>29/07/2026</a:t>
             </a:fld>
             <a:endParaRPr lang="en-DE"/>
           </a:p>
@@ -2925,7 +2930,7 @@
           <a:p>
             <a:fld id="{FDD66248-7FCF-479B-9C79-503AAD01293A}" type="datetimeFigureOut">
               <a:rPr lang="en-DE" smtClean="0"/>
-              <a:t>23/07/2026</a:t>
+              <a:t>29/07/2026</a:t>
             </a:fld>
             <a:endParaRPr lang="en-DE"/>
           </a:p>
@@ -3344,10 +3349,10 @@
       </p:grpSpPr>
       <p:pic>
         <p:nvPicPr>
-          <p:cNvPr id="5" name="Picture 4">
-            <a:extLst>
-              <a:ext uri="{FF2B5EF4-FFF2-40B4-BE49-F238E27FC236}">
-                <a16:creationId xmlns:a16="http://schemas.microsoft.com/office/drawing/2014/main" id="{B121CBF7-52EF-5C4B-D1EA-2AC804695B1B}"/>
+          <p:cNvPr id="11" name="Picture 10">
+            <a:extLst>
+              <a:ext uri="{FF2B5EF4-FFF2-40B4-BE49-F238E27FC236}">
+                <a16:creationId xmlns:a16="http://schemas.microsoft.com/office/drawing/2014/main" id="{787233FE-C23A-E49F-F3C3-D641373867C9}"/>
               </a:ext>
             </a:extLst>
           </p:cNvPr>
@@ -3358,117 +3363,6 @@
         </p:nvPicPr>
         <p:blipFill>
           <a:blip r:embed="rId2">
-            <a:extLst>
-              <a:ext uri="{28A0092B-C50C-407E-A947-70E740481C1C}">
-                <a14:useLocalDpi xmlns:a14="http://schemas.microsoft.com/office/drawing/2010/main" val="0"/>
-              </a:ext>
-            </a:extLst>
-          </a:blip>
-          <a:srcRect b="29678"/>
-          <a:stretch>
-            <a:fillRect/>
-          </a:stretch>
-        </p:blipFill>
-        <p:spPr>
-          <a:xfrm>
-            <a:off x="2382932" y="3673515"/>
-            <a:ext cx="1950437" cy="694026"/>
-          </a:xfrm>
-          <a:prstGeom prst="rect">
-            <a:avLst/>
-          </a:prstGeom>
-        </p:spPr>
-      </p:pic>
-      <p:pic>
-        <p:nvPicPr>
-          <p:cNvPr id="7" name="Picture 6">
-            <a:extLst>
-              <a:ext uri="{FF2B5EF4-FFF2-40B4-BE49-F238E27FC236}">
-                <a16:creationId xmlns:a16="http://schemas.microsoft.com/office/drawing/2014/main" id="{4D6809C6-68CE-F8EA-95C7-77BE7B47949D}"/>
-              </a:ext>
-            </a:extLst>
-          </p:cNvPr>
-          <p:cNvPicPr>
-            <a:picLocks noChangeAspect="1"/>
-          </p:cNvPicPr>
-          <p:nvPr/>
-        </p:nvPicPr>
-        <p:blipFill>
-          <a:blip r:embed="rId3">
-            <a:extLst>
-              <a:ext uri="{28A0092B-C50C-407E-A947-70E740481C1C}">
-                <a14:useLocalDpi xmlns:a14="http://schemas.microsoft.com/office/drawing/2010/main" val="0"/>
-              </a:ext>
-            </a:extLst>
-          </a:blip>
-          <a:srcRect b="12631"/>
-          <a:stretch>
-            <a:fillRect/>
-          </a:stretch>
-        </p:blipFill>
-        <p:spPr>
-          <a:xfrm>
-            <a:off x="4398185" y="2812451"/>
-            <a:ext cx="1950436" cy="720033"/>
-          </a:xfrm>
-          <a:prstGeom prst="rect">
-            <a:avLst/>
-          </a:prstGeom>
-        </p:spPr>
-      </p:pic>
-      <p:pic>
-        <p:nvPicPr>
-          <p:cNvPr id="9" name="Picture 8">
-            <a:extLst>
-              <a:ext uri="{FF2B5EF4-FFF2-40B4-BE49-F238E27FC236}">
-                <a16:creationId xmlns:a16="http://schemas.microsoft.com/office/drawing/2014/main" id="{5B34161D-3687-A98E-B78B-A710FE6D2BF2}"/>
-              </a:ext>
-            </a:extLst>
-          </p:cNvPr>
-          <p:cNvPicPr>
-            <a:picLocks noChangeAspect="1"/>
-          </p:cNvPicPr>
-          <p:nvPr/>
-        </p:nvPicPr>
-        <p:blipFill>
-          <a:blip r:embed="rId4">
-            <a:extLst>
-              <a:ext uri="{28A0092B-C50C-407E-A947-70E740481C1C}">
-                <a14:useLocalDpi xmlns:a14="http://schemas.microsoft.com/office/drawing/2010/main" val="0"/>
-              </a:ext>
-            </a:extLst>
-          </a:blip>
-          <a:srcRect b="34652"/>
-          <a:stretch>
-            <a:fillRect/>
-          </a:stretch>
-        </p:blipFill>
-        <p:spPr>
-          <a:xfrm>
-            <a:off x="764591" y="2815544"/>
-            <a:ext cx="1947390" cy="716940"/>
-          </a:xfrm>
-          <a:prstGeom prst="rect">
-            <a:avLst/>
-          </a:prstGeom>
-        </p:spPr>
-      </p:pic>
-      <p:pic>
-        <p:nvPicPr>
-          <p:cNvPr id="11" name="Picture 10">
-            <a:extLst>
-              <a:ext uri="{FF2B5EF4-FFF2-40B4-BE49-F238E27FC236}">
-                <a16:creationId xmlns:a16="http://schemas.microsoft.com/office/drawing/2014/main" id="{787233FE-C23A-E49F-F3C3-D641373867C9}"/>
-              </a:ext>
-            </a:extLst>
-          </p:cNvPr>
-          <p:cNvPicPr>
-            <a:picLocks noChangeAspect="1"/>
-          </p:cNvPicPr>
-          <p:nvPr/>
-        </p:nvPicPr>
-        <p:blipFill>
-          <a:blip r:embed="rId5">
             <a:extLst>
               <a:ext uri="{28A0092B-C50C-407E-A947-70E740481C1C}">
                 <a14:useLocalDpi xmlns:a14="http://schemas.microsoft.com/office/drawing/2010/main" val="0"/>
@@ -3548,7 +3442,7 @@
         <p:spPr>
           <a:xfrm>
             <a:off x="3358151" y="1390650"/>
-            <a:ext cx="0" cy="2190750"/>
+            <a:ext cx="0" cy="1889445"/>
           </a:xfrm>
           <a:prstGeom prst="straightConnector1">
             <a:avLst/>
@@ -3613,6 +3507,117 @@
           </a:fontRef>
         </p:style>
       </p:cxnSp>
+      <p:pic>
+        <p:nvPicPr>
+          <p:cNvPr id="3" name="Picture 2">
+            <a:extLst>
+              <a:ext uri="{FF2B5EF4-FFF2-40B4-BE49-F238E27FC236}">
+                <a16:creationId xmlns:a16="http://schemas.microsoft.com/office/drawing/2014/main" id="{BDABA859-51C1-C6F8-FDBC-597936E0886A}"/>
+              </a:ext>
+            </a:extLst>
+          </p:cNvPr>
+          <p:cNvPicPr>
+            <a:picLocks noChangeAspect="1"/>
+          </p:cNvPicPr>
+          <p:nvPr/>
+        </p:nvPicPr>
+        <p:blipFill>
+          <a:blip r:embed="rId3">
+            <a:extLst>
+              <a:ext uri="{28A0092B-C50C-407E-A947-70E740481C1C}">
+                <a14:useLocalDpi xmlns:a14="http://schemas.microsoft.com/office/drawing/2010/main" val="0"/>
+              </a:ext>
+            </a:extLst>
+          </a:blip>
+          <a:srcRect b="37244"/>
+          <a:stretch>
+            <a:fillRect/>
+          </a:stretch>
+        </p:blipFill>
+        <p:spPr>
+          <a:xfrm>
+            <a:off x="2462687" y="3344626"/>
+            <a:ext cx="2002817" cy="684875"/>
+          </a:xfrm>
+          <a:prstGeom prst="rect">
+            <a:avLst/>
+          </a:prstGeom>
+        </p:spPr>
+      </p:pic>
+      <p:pic>
+        <p:nvPicPr>
+          <p:cNvPr id="6" name="Picture 5">
+            <a:extLst>
+              <a:ext uri="{FF2B5EF4-FFF2-40B4-BE49-F238E27FC236}">
+                <a16:creationId xmlns:a16="http://schemas.microsoft.com/office/drawing/2014/main" id="{B379FEC4-28DD-EE4E-877C-804C76D9CB12}"/>
+              </a:ext>
+            </a:extLst>
+          </p:cNvPr>
+          <p:cNvPicPr>
+            <a:picLocks noChangeAspect="1"/>
+          </p:cNvPicPr>
+          <p:nvPr/>
+        </p:nvPicPr>
+        <p:blipFill>
+          <a:blip r:embed="rId4">
+            <a:extLst>
+              <a:ext uri="{28A0092B-C50C-407E-A947-70E740481C1C}">
+                <a14:useLocalDpi xmlns:a14="http://schemas.microsoft.com/office/drawing/2010/main" val="0"/>
+              </a:ext>
+            </a:extLst>
+          </a:blip>
+          <a:srcRect t="-2" b="36410"/>
+          <a:stretch>
+            <a:fillRect/>
+          </a:stretch>
+        </p:blipFill>
+        <p:spPr>
+          <a:xfrm>
+            <a:off x="4391487" y="2758499"/>
+            <a:ext cx="2002817" cy="705524"/>
+          </a:xfrm>
+          <a:prstGeom prst="rect">
+            <a:avLst/>
+          </a:prstGeom>
+        </p:spPr>
+      </p:pic>
+      <p:pic>
+        <p:nvPicPr>
+          <p:cNvPr id="10" name="Picture 9">
+            <a:extLst>
+              <a:ext uri="{FF2B5EF4-FFF2-40B4-BE49-F238E27FC236}">
+                <a16:creationId xmlns:a16="http://schemas.microsoft.com/office/drawing/2014/main" id="{04C3A629-8E47-6F01-8734-ADF0FD28F16D}"/>
+              </a:ext>
+            </a:extLst>
+          </p:cNvPr>
+          <p:cNvPicPr>
+            <a:picLocks noChangeAspect="1"/>
+          </p:cNvPicPr>
+          <p:nvPr/>
+        </p:nvPicPr>
+        <p:blipFill>
+          <a:blip r:embed="rId5">
+            <a:extLst>
+              <a:ext uri="{28A0092B-C50C-407E-A947-70E740481C1C}">
+                <a14:useLocalDpi xmlns:a14="http://schemas.microsoft.com/office/drawing/2010/main" val="0"/>
+              </a:ext>
+            </a:extLst>
+          </a:blip>
+          <a:srcRect b="39208"/>
+          <a:stretch>
+            <a:fillRect/>
+          </a:stretch>
+        </p:blipFill>
+        <p:spPr>
+          <a:xfrm>
+            <a:off x="731130" y="2733675"/>
+            <a:ext cx="1895264" cy="684874"/>
+          </a:xfrm>
+          <a:prstGeom prst="rect">
+            <a:avLst/>
+          </a:prstGeom>
+        </p:spPr>
+      </p:pic>
     </p:spTree>
     <p:extLst>
       <p:ext uri="{BB962C8B-B14F-4D97-AF65-F5344CB8AC3E}">

</xml_diff>